<commit_message>
Word export: keep tables as tables, even from crooked photos
- Pages tilted 0.25° or more are straightened before layout analysis.
- Table rules are found where a photo bends them: rows and columns look
  for the rule a little to the side, and line thickness is measured from
  the ink instead of the height a slightly askew rule drifts over. Labels
  in neighbouring merged cells (TOT / USA1 / USA2) no longer run together.
- Small recognition slips are tidied: spaces inside dotted numbers
  ("10.41.22. xx") and a closing bracket missing in a bracketed column.
- The Word review shows tables as tables with merged cells and colours;
  tap a cell to correct it. Lines stay editable fields, and plain-text
  editing is still available.

Co-Authored-By: Claude Opus 5.5 <noreply@anthropic.com>
Claude-Session: https://claude.ai/code/session_01N2KPqXq9Whv7eR2vrvkBWC
</commit_message>
<xml_diff>
--- a/ios/Verification/office-layout/OfficeSampleTable.pptx
+++ b/ios/Verification/office-layout/OfficeSampleTable.pptx
@@ -102,15 +102,15 @@
           <p:nvPr/>
         </p:nvGraphicFramePr>
         <p:xfrm>
-          <a:off x="656327" y="844046"/>
-          <a:ext cx="6390387" cy="5820260"/>
+          <a:off x="660468" y="844046"/>
+          <a:ext cx="6386246" cy="5820260"/>
         </p:xfrm>
         <a:graphic>
           <a:graphicData uri="http://schemas.openxmlformats.org/drawingml/2006/table">
             <a:tbl>
               <a:tblPr/>
               <a:tblGrid>
-                <a:gridCol w="650116"/>
+                <a:gridCol w="645975"/>
                 <a:gridCol w="1744856"/>
                 <a:gridCol w="2094414"/>
                 <a:gridCol w="668749"/>
@@ -313,7 +313,7 @@
                           <a:ea typeface="Malgun Gothic"/>
                           <a:cs typeface="Arial"/>
                         </a:rPr>
-                        <a:t>10.41.22. xx</a:t>
+                        <a:t>10.41.22.xx</a:t>
                       </a:r>
                     </a:p>
                   </a:txBody>
@@ -2120,7 +2120,7 @@
                   </a:tcPr>
                 </a:tc>
               </a:tr>
-              <a:tr h="173916">
+              <a:tr h="176677">
                 <a:tc vMerge="1">
                   <a:txBody>
                     <a:bodyPr/>
@@ -2339,7 +2339,7 @@
                   </a:tcPr>
                 </a:tc>
               </a:tr>
-              <a:tr h="203938">
+              <a:tr h="201177">
                 <a:tc rowSpan="2">
                   <a:txBody>
                     <a:bodyPr/>
@@ -2837,7 +2837,7 @@
                       <a:prstDash val="solid"/>
                     </a:lnB>
                     <a:solidFill>
-                      <a:srgbClr val="FDE6E2"/>
+                      <a:srgbClr val="FBE6E2"/>
                     </a:solidFill>
                   </a:tcPr>
                 </a:tc>
@@ -3067,7 +3067,7 @@
                       <a:prstDash val="solid"/>
                     </a:lnB>
                     <a:solidFill>
-                      <a:srgbClr val="FDE6E2"/>
+                      <a:srgbClr val="FBE6E2"/>
                     </a:solidFill>
                   </a:tcPr>
                 </a:tc>
@@ -3286,7 +3286,7 @@
                       <a:prstDash val="solid"/>
                     </a:lnB>
                     <a:solidFill>
-                      <a:srgbClr val="FDE6E2"/>
+                      <a:srgbClr val="FBE6E2"/>
                     </a:solidFill>
                   </a:tcPr>
                 </a:tc>
@@ -3505,7 +3505,7 @@
                       <a:prstDash val="solid"/>
                     </a:lnB>
                     <a:solidFill>
-                      <a:srgbClr val="FDE6E2"/>
+                      <a:srgbClr val="FBE6E2"/>
                     </a:solidFill>
                   </a:tcPr>
                 </a:tc>
@@ -3724,7 +3724,7 @@
                       <a:prstDash val="solid"/>
                     </a:lnB>
                     <a:solidFill>
-                      <a:srgbClr val="FDE6E2"/>
+                      <a:srgbClr val="FBE6E2"/>
                     </a:solidFill>
                   </a:tcPr>
                 </a:tc>
@@ -3943,7 +3943,7 @@
                       <a:prstDash val="solid"/>
                     </a:lnB>
                     <a:solidFill>
-                      <a:srgbClr val="FDE6E2"/>
+                      <a:srgbClr val="FBE6E2"/>
                     </a:solidFill>
                   </a:tcPr>
                 </a:tc>
@@ -4162,7 +4162,7 @@
                       <a:prstDash val="solid"/>
                     </a:lnB>
                     <a:solidFill>
-                      <a:srgbClr val="FDE6E2"/>
+                      <a:srgbClr val="FBE6E2"/>
                     </a:solidFill>
                   </a:tcPr>
                 </a:tc>
@@ -4844,7 +4844,7 @@
                       <a:prstDash val="solid"/>
                     </a:lnB>
                     <a:solidFill>
-                      <a:srgbClr val="F8DF71"/>
+                      <a:srgbClr val="F7DE72"/>
                     </a:solidFill>
                   </a:tcPr>
                 </a:tc>

</xml_diff>

<commit_message>
Page frame and heading bars in Office export, receipt fixes, UVDoc benchmark, flatten by surface length
- Page-wide frame becomes a Word page border; dark and gray heading bars become paragraph shading
- Fix out-of-range read in Ink.fill (crash on pages with text near the edge)
- Pictures made mostly of recognized words keep only the unread ink (no doubled receipt totals)
- One-line paragraphs no taller than the room to the next line; short words capped by width
- Accept confident document segmentation on heavily printed pages; prefer the sheet over a printed rectangle inside it
- Snap aspect to the nearest paper size; lay out the flattened page by surface arc length
- UVDoc benchmark test and scorer support

Co-Authored-By: Claude Opus 5.5 <noreply@anthropic.com>
Claude-Session: https://claude.ai/code/session_01N2KPqXq9Whv7eR2vrvkBWC
</commit_message>
<xml_diff>
--- a/ios/Verification/office-layout/OfficeSampleTable.pptx
+++ b/ios/Verification/office-layout/OfficeSampleTable.pptx
@@ -162,7 +162,7 @@
                       <a:prstDash val="solid"/>
                     </a:lnB>
                     <a:solidFill>
-                      <a:srgbClr val="E4EDFA"/>
+                      <a:srgbClr val="DDEBF7"/>
                     </a:solidFill>
                   </a:tcPr>
                 </a:tc>
@@ -200,7 +200,7 @@
                       <a:prstDash val="solid"/>
                     </a:lnB>
                     <a:solidFill>
-                      <a:srgbClr val="E4EDFA"/>
+                      <a:srgbClr val="DDEBF7"/>
                     </a:solidFill>
                   </a:tcPr>
                 </a:tc>
@@ -248,7 +248,9 @@
                       </a:solidFill>
                       <a:prstDash val="solid"/>
                     </a:lnB>
-                    <a:noFill/>
+                    <a:solidFill>
+                      <a:srgbClr val="DDEBF7"/>
+                    </a:solidFill>
                   </a:tcPr>
                 </a:tc>
                 <a:tc>
@@ -295,7 +297,9 @@
                       </a:solidFill>
                       <a:prstDash val="solid"/>
                     </a:lnB>
-                    <a:noFill/>
+                    <a:solidFill>
+                      <a:srgbClr val="DDEBF7"/>
+                    </a:solidFill>
                   </a:tcPr>
                 </a:tc>
                 <a:tc>
@@ -342,7 +346,9 @@
                       </a:solidFill>
                       <a:prstDash val="solid"/>
                     </a:lnB>
-                    <a:noFill/>
+                    <a:solidFill>
+                      <a:srgbClr val="DDEBF7"/>
+                    </a:solidFill>
                   </a:tcPr>
                 </a:tc>
               </a:tr>
@@ -381,7 +387,7 @@
                       <a:prstDash val="solid"/>
                     </a:lnB>
                     <a:solidFill>
-                      <a:srgbClr val="E4EDFA"/>
+                      <a:srgbClr val="DDEBF7"/>
                     </a:solidFill>
                   </a:tcPr>
                 </a:tc>
@@ -419,7 +425,7 @@
                       <a:prstDash val="solid"/>
                     </a:lnB>
                     <a:solidFill>
-                      <a:srgbClr val="E4EDFA"/>
+                      <a:srgbClr val="DDEBF7"/>
                     </a:solidFill>
                   </a:tcPr>
                 </a:tc>
@@ -467,7 +473,9 @@
                       </a:solidFill>
                       <a:prstDash val="solid"/>
                     </a:lnB>
-                    <a:noFill/>
+                    <a:solidFill>
+                      <a:srgbClr val="DDEBF7"/>
+                    </a:solidFill>
                   </a:tcPr>
                 </a:tc>
                 <a:tc>
@@ -514,7 +522,9 @@
                       </a:solidFill>
                       <a:prstDash val="solid"/>
                     </a:lnB>
-                    <a:noFill/>
+                    <a:solidFill>
+                      <a:srgbClr val="DDEBF7"/>
+                    </a:solidFill>
                   </a:tcPr>
                 </a:tc>
                 <a:tc>
@@ -561,7 +571,9 @@
                       </a:solidFill>
                       <a:prstDash val="solid"/>
                     </a:lnB>
-                    <a:noFill/>
+                    <a:solidFill>
+                      <a:srgbClr val="DDEBF7"/>
+                    </a:solidFill>
                   </a:tcPr>
                 </a:tc>
               </a:tr>
@@ -600,7 +612,7 @@
                       <a:prstDash val="solid"/>
                     </a:lnB>
                     <a:solidFill>
-                      <a:srgbClr val="E4EDFA"/>
+                      <a:srgbClr val="DDEBF7"/>
                     </a:solidFill>
                   </a:tcPr>
                 </a:tc>
@@ -638,7 +650,7 @@
                       <a:prstDash val="solid"/>
                     </a:lnB>
                     <a:solidFill>
-                      <a:srgbClr val="E4EDFA"/>
+                      <a:srgbClr val="DDEBF7"/>
                     </a:solidFill>
                   </a:tcPr>
                 </a:tc>
@@ -686,7 +698,9 @@
                       </a:solidFill>
                       <a:prstDash val="solid"/>
                     </a:lnB>
-                    <a:noFill/>
+                    <a:solidFill>
+                      <a:srgbClr val="DDEBF7"/>
+                    </a:solidFill>
                   </a:tcPr>
                 </a:tc>
                 <a:tc>
@@ -733,7 +747,9 @@
                       </a:solidFill>
                       <a:prstDash val="solid"/>
                     </a:lnB>
-                    <a:noFill/>
+                    <a:solidFill>
+                      <a:srgbClr val="DDEBF7"/>
+                    </a:solidFill>
                   </a:tcPr>
                 </a:tc>
                 <a:tc>
@@ -780,7 +796,9 @@
                       </a:solidFill>
                       <a:prstDash val="solid"/>
                     </a:lnB>
-                    <a:noFill/>
+                    <a:solidFill>
+                      <a:srgbClr val="DDEBF7"/>
+                    </a:solidFill>
                   </a:tcPr>
                 </a:tc>
               </a:tr>
@@ -830,7 +848,7 @@
                       <a:prstDash val="solid"/>
                     </a:lnB>
                     <a:solidFill>
-                      <a:srgbClr val="FDF3CF"/>
+                      <a:srgbClr val="FFF2CC"/>
                     </a:solidFill>
                   </a:tcPr>
                 </a:tc>
@@ -879,7 +897,7 @@
                       <a:prstDash val="solid"/>
                     </a:lnB>
                     <a:solidFill>
-                      <a:srgbClr val="FBF8D2"/>
+                      <a:srgbClr val="FFF2CC"/>
                     </a:solidFill>
                   </a:tcPr>
                 </a:tc>
@@ -927,7 +945,9 @@
                       </a:solidFill>
                       <a:prstDash val="solid"/>
                     </a:lnB>
-                    <a:noFill/>
+                    <a:solidFill>
+                      <a:srgbClr val="FFF2CC"/>
+                    </a:solidFill>
                   </a:tcPr>
                 </a:tc>
                 <a:tc>
@@ -974,7 +994,9 @@
                       </a:solidFill>
                       <a:prstDash val="solid"/>
                     </a:lnB>
-                    <a:noFill/>
+                    <a:solidFill>
+                      <a:srgbClr val="FFF2CC"/>
+                    </a:solidFill>
                   </a:tcPr>
                 </a:tc>
                 <a:tc>
@@ -1021,7 +1043,9 @@
                       </a:solidFill>
                       <a:prstDash val="solid"/>
                     </a:lnB>
-                    <a:noFill/>
+                    <a:solidFill>
+                      <a:srgbClr val="FFF2CC"/>
+                    </a:solidFill>
                   </a:tcPr>
                 </a:tc>
               </a:tr>
@@ -1060,7 +1084,7 @@
                       <a:prstDash val="solid"/>
                     </a:lnB>
                     <a:solidFill>
-                      <a:srgbClr val="FDF3CF"/>
+                      <a:srgbClr val="FFF2CC"/>
                     </a:solidFill>
                   </a:tcPr>
                 </a:tc>
@@ -1098,7 +1122,7 @@
                       <a:prstDash val="solid"/>
                     </a:lnB>
                     <a:solidFill>
-                      <a:srgbClr val="FBF8D2"/>
+                      <a:srgbClr val="FFF2CC"/>
                     </a:solidFill>
                   </a:tcPr>
                 </a:tc>
@@ -1146,7 +1170,9 @@
                       </a:solidFill>
                       <a:prstDash val="solid"/>
                     </a:lnB>
-                    <a:noFill/>
+                    <a:solidFill>
+                      <a:srgbClr val="FFF2CC"/>
+                    </a:solidFill>
                   </a:tcPr>
                 </a:tc>
                 <a:tc>
@@ -1193,7 +1219,9 @@
                       </a:solidFill>
                       <a:prstDash val="solid"/>
                     </a:lnB>
-                    <a:noFill/>
+                    <a:solidFill>
+                      <a:srgbClr val="FFF2CC"/>
+                    </a:solidFill>
                   </a:tcPr>
                 </a:tc>
                 <a:tc>
@@ -1240,7 +1268,9 @@
                       </a:solidFill>
                       <a:prstDash val="solid"/>
                     </a:lnB>
-                    <a:noFill/>
+                    <a:solidFill>
+                      <a:srgbClr val="FFF2CC"/>
+                    </a:solidFill>
                   </a:tcPr>
                 </a:tc>
               </a:tr>
@@ -1279,7 +1309,7 @@
                       <a:prstDash val="solid"/>
                     </a:lnB>
                     <a:solidFill>
-                      <a:srgbClr val="FDF3CF"/>
+                      <a:srgbClr val="FFF2CC"/>
                     </a:solidFill>
                   </a:tcPr>
                 </a:tc>
@@ -1317,7 +1347,7 @@
                       <a:prstDash val="solid"/>
                     </a:lnB>
                     <a:solidFill>
-                      <a:srgbClr val="FBF8D2"/>
+                      <a:srgbClr val="FFF2CC"/>
                     </a:solidFill>
                   </a:tcPr>
                 </a:tc>
@@ -1365,7 +1395,9 @@
                       </a:solidFill>
                       <a:prstDash val="solid"/>
                     </a:lnB>
-                    <a:noFill/>
+                    <a:solidFill>
+                      <a:srgbClr val="FFF2CC"/>
+                    </a:solidFill>
                   </a:tcPr>
                 </a:tc>
                 <a:tc>
@@ -1412,7 +1444,9 @@
                       </a:solidFill>
                       <a:prstDash val="solid"/>
                     </a:lnB>
-                    <a:noFill/>
+                    <a:solidFill>
+                      <a:srgbClr val="FFF2CC"/>
+                    </a:solidFill>
                   </a:tcPr>
                 </a:tc>
                 <a:tc>
@@ -1459,7 +1493,9 @@
                       </a:solidFill>
                       <a:prstDash val="solid"/>
                     </a:lnB>
-                    <a:noFill/>
+                    <a:solidFill>
+                      <a:srgbClr val="FFF2CC"/>
+                    </a:solidFill>
                   </a:tcPr>
                 </a:tc>
               </a:tr>
@@ -1498,7 +1534,7 @@
                       <a:prstDash val="solid"/>
                     </a:lnB>
                     <a:solidFill>
-                      <a:srgbClr val="FDF3CF"/>
+                      <a:srgbClr val="FFF2CC"/>
                     </a:solidFill>
                   </a:tcPr>
                 </a:tc>
@@ -1536,7 +1572,7 @@
                       <a:prstDash val="solid"/>
                     </a:lnB>
                     <a:solidFill>
-                      <a:srgbClr val="FBF8D2"/>
+                      <a:srgbClr val="FFF2CC"/>
                     </a:solidFill>
                   </a:tcPr>
                 </a:tc>
@@ -1584,7 +1620,9 @@
                       </a:solidFill>
                       <a:prstDash val="solid"/>
                     </a:lnB>
-                    <a:noFill/>
+                    <a:solidFill>
+                      <a:srgbClr val="FFF2CC"/>
+                    </a:solidFill>
                   </a:tcPr>
                 </a:tc>
                 <a:tc>
@@ -1631,7 +1669,9 @@
                       </a:solidFill>
                       <a:prstDash val="solid"/>
                     </a:lnB>
-                    <a:noFill/>
+                    <a:solidFill>
+                      <a:srgbClr val="FFF2CC"/>
+                    </a:solidFill>
                   </a:tcPr>
                 </a:tc>
                 <a:tc>
@@ -1678,7 +1718,9 @@
                       </a:solidFill>
                       <a:prstDash val="solid"/>
                     </a:lnB>
-                    <a:noFill/>
+                    <a:solidFill>
+                      <a:srgbClr val="FFF2CC"/>
+                    </a:solidFill>
                   </a:tcPr>
                 </a:tc>
               </a:tr>
@@ -1717,7 +1759,7 @@
                       <a:prstDash val="solid"/>
                     </a:lnB>
                     <a:solidFill>
-                      <a:srgbClr val="FDF3CF"/>
+                      <a:srgbClr val="FFF2CC"/>
                     </a:solidFill>
                   </a:tcPr>
                 </a:tc>
@@ -1755,7 +1797,7 @@
                       <a:prstDash val="solid"/>
                     </a:lnB>
                     <a:solidFill>
-                      <a:srgbClr val="FBF8D2"/>
+                      <a:srgbClr val="FFF2CC"/>
                     </a:solidFill>
                   </a:tcPr>
                 </a:tc>
@@ -1774,36 +1816,38 @@
                           <a:ea typeface="Malgun Gothic"/>
                           <a:cs typeface="Arial"/>
                         </a:rPr>
-                        <a:t>Richmond HII(리치몬드 힐)</a:t>
-                      </a:r>
-                    </a:p>
-                  </a:txBody>
-                  <a:tcPr marL="45720" marR="45720" marT="0" marB="0" anchor="ctr">
-                    <a:lnL w="12700" cap="flat" cmpd="sng" algn="ctr">
-                      <a:solidFill>
-                        <a:srgbClr val="000000"/>
-                      </a:solidFill>
-                      <a:prstDash val="solid"/>
-                    </a:lnL>
-                    <a:lnR w="12700" cap="flat" cmpd="sng" algn="ctr">
-                      <a:solidFill>
-                        <a:srgbClr val="000000"/>
-                      </a:solidFill>
-                      <a:prstDash val="solid"/>
-                    </a:lnR>
-                    <a:lnT w="12700" cap="flat" cmpd="sng" algn="ctr">
-                      <a:solidFill>
-                        <a:srgbClr val="000000"/>
-                      </a:solidFill>
-                      <a:prstDash val="solid"/>
-                    </a:lnT>
-                    <a:lnB w="12700" cap="flat" cmpd="sng" algn="ctr">
-                      <a:solidFill>
-                        <a:srgbClr val="000000"/>
-                      </a:solidFill>
-                      <a:prstDash val="solid"/>
-                    </a:lnB>
-                    <a:noFill/>
+                        <a:t>Richmond Hill(리치몬드 힐)</a:t>
+                      </a:r>
+                    </a:p>
+                  </a:txBody>
+                  <a:tcPr marL="45720" marR="45720" marT="0" marB="0" anchor="ctr">
+                    <a:lnL w="12700" cap="flat" cmpd="sng" algn="ctr">
+                      <a:solidFill>
+                        <a:srgbClr val="000000"/>
+                      </a:solidFill>
+                      <a:prstDash val="solid"/>
+                    </a:lnL>
+                    <a:lnR w="12700" cap="flat" cmpd="sng" algn="ctr">
+                      <a:solidFill>
+                        <a:srgbClr val="000000"/>
+                      </a:solidFill>
+                      <a:prstDash val="solid"/>
+                    </a:lnR>
+                    <a:lnT w="12700" cap="flat" cmpd="sng" algn="ctr">
+                      <a:solidFill>
+                        <a:srgbClr val="000000"/>
+                      </a:solidFill>
+                      <a:prstDash val="solid"/>
+                    </a:lnT>
+                    <a:lnB w="12700" cap="flat" cmpd="sng" algn="ctr">
+                      <a:solidFill>
+                        <a:srgbClr val="000000"/>
+                      </a:solidFill>
+                      <a:prstDash val="solid"/>
+                    </a:lnB>
+                    <a:solidFill>
+                      <a:srgbClr val="FFF2CC"/>
+                    </a:solidFill>
                   </a:tcPr>
                 </a:tc>
                 <a:tc>
@@ -1850,7 +1894,9 @@
                       </a:solidFill>
                       <a:prstDash val="solid"/>
                     </a:lnB>
-                    <a:noFill/>
+                    <a:solidFill>
+                      <a:srgbClr val="FFF2CC"/>
+                    </a:solidFill>
                   </a:tcPr>
                 </a:tc>
                 <a:tc>
@@ -1897,7 +1943,9 @@
                       </a:solidFill>
                       <a:prstDash val="solid"/>
                     </a:lnB>
-                    <a:noFill/>
+                    <a:solidFill>
+                      <a:srgbClr val="FFF2CC"/>
+                    </a:solidFill>
                   </a:tcPr>
                 </a:tc>
               </a:tr>
@@ -1936,7 +1984,7 @@
                       <a:prstDash val="solid"/>
                     </a:lnB>
                     <a:solidFill>
-                      <a:srgbClr val="FDF3CF"/>
+                      <a:srgbClr val="FFF2CC"/>
                     </a:solidFill>
                   </a:tcPr>
                 </a:tc>
@@ -1974,7 +2022,7 @@
                       <a:prstDash val="solid"/>
                     </a:lnB>
                     <a:solidFill>
-                      <a:srgbClr val="FBF8D2"/>
+                      <a:srgbClr val="FFF2CC"/>
                     </a:solidFill>
                   </a:tcPr>
                 </a:tc>
@@ -2022,7 +2070,9 @@
                       </a:solidFill>
                       <a:prstDash val="solid"/>
                     </a:lnB>
-                    <a:noFill/>
+                    <a:solidFill>
+                      <a:srgbClr val="FFF2CC"/>
+                    </a:solidFill>
                   </a:tcPr>
                 </a:tc>
                 <a:tc>
@@ -2069,7 +2119,9 @@
                       </a:solidFill>
                       <a:prstDash val="solid"/>
                     </a:lnB>
-                    <a:noFill/>
+                    <a:solidFill>
+                      <a:srgbClr val="FFF2CC"/>
+                    </a:solidFill>
                   </a:tcPr>
                 </a:tc>
                 <a:tc>
@@ -2116,7 +2168,9 @@
                       </a:solidFill>
                       <a:prstDash val="solid"/>
                     </a:lnB>
-                    <a:noFill/>
+                    <a:solidFill>
+                      <a:srgbClr val="FFF2CC"/>
+                    </a:solidFill>
                   </a:tcPr>
                 </a:tc>
               </a:tr>
@@ -2155,7 +2209,7 @@
                       <a:prstDash val="solid"/>
                     </a:lnB>
                     <a:solidFill>
-                      <a:srgbClr val="FDF3CF"/>
+                      <a:srgbClr val="FFF2CC"/>
                     </a:solidFill>
                   </a:tcPr>
                 </a:tc>
@@ -2193,7 +2247,7 @@
                       <a:prstDash val="solid"/>
                     </a:lnB>
                     <a:solidFill>
-                      <a:srgbClr val="FBF8D2"/>
+                      <a:srgbClr val="FFF2CC"/>
                     </a:solidFill>
                   </a:tcPr>
                 </a:tc>
@@ -2241,7 +2295,9 @@
                       </a:solidFill>
                       <a:prstDash val="solid"/>
                     </a:lnB>
-                    <a:noFill/>
+                    <a:solidFill>
+                      <a:srgbClr val="FFF2CC"/>
+                    </a:solidFill>
                   </a:tcPr>
                 </a:tc>
                 <a:tc>
@@ -2288,7 +2344,9 @@
                       </a:solidFill>
                       <a:prstDash val="solid"/>
                     </a:lnB>
-                    <a:noFill/>
+                    <a:solidFill>
+                      <a:srgbClr val="FFF2CC"/>
+                    </a:solidFill>
                   </a:tcPr>
                 </a:tc>
                 <a:tc>
@@ -2335,7 +2393,9 @@
                       </a:solidFill>
                       <a:prstDash val="solid"/>
                     </a:lnB>
-                    <a:noFill/>
+                    <a:solidFill>
+                      <a:srgbClr val="FFF2CC"/>
+                    </a:solidFill>
                   </a:tcPr>
                 </a:tc>
               </a:tr>
@@ -2384,7 +2444,9 @@
                       </a:solidFill>
                       <a:prstDash val="solid"/>
                     </a:lnB>
-                    <a:noFill/>
+                    <a:solidFill>
+                      <a:srgbClr val="DDEBF7"/>
+                    </a:solidFill>
                   </a:tcPr>
                 </a:tc>
                 <a:tc rowSpan="2">
@@ -2431,7 +2493,9 @@
                       </a:solidFill>
                       <a:prstDash val="solid"/>
                     </a:lnB>
-                    <a:noFill/>
+                    <a:solidFill>
+                      <a:srgbClr val="DDEBF7"/>
+                    </a:solidFill>
                   </a:tcPr>
                 </a:tc>
                 <a:tc>
@@ -2478,7 +2542,9 @@
                       </a:solidFill>
                       <a:prstDash val="solid"/>
                     </a:lnB>
-                    <a:noFill/>
+                    <a:solidFill>
+                      <a:srgbClr val="DDEBF7"/>
+                    </a:solidFill>
                   </a:tcPr>
                 </a:tc>
                 <a:tc>
@@ -2525,7 +2591,9 @@
                       </a:solidFill>
                       <a:prstDash val="solid"/>
                     </a:lnB>
-                    <a:noFill/>
+                    <a:solidFill>
+                      <a:srgbClr val="DDEBF7"/>
+                    </a:solidFill>
                   </a:tcPr>
                 </a:tc>
                 <a:tc>
@@ -2572,7 +2640,9 @@
                       </a:solidFill>
                       <a:prstDash val="solid"/>
                     </a:lnB>
-                    <a:noFill/>
+                    <a:solidFill>
+                      <a:srgbClr val="DDEBF7"/>
+                    </a:solidFill>
                   </a:tcPr>
                 </a:tc>
               </a:tr>
@@ -2610,7 +2680,9 @@
                       </a:solidFill>
                       <a:prstDash val="solid"/>
                     </a:lnB>
-                    <a:noFill/>
+                    <a:solidFill>
+                      <a:srgbClr val="DDEBF7"/>
+                    </a:solidFill>
                   </a:tcPr>
                 </a:tc>
                 <a:tc vMerge="1">
@@ -2646,7 +2718,9 @@
                       </a:solidFill>
                       <a:prstDash val="solid"/>
                     </a:lnB>
-                    <a:noFill/>
+                    <a:solidFill>
+                      <a:srgbClr val="DDEBF7"/>
+                    </a:solidFill>
                   </a:tcPr>
                 </a:tc>
                 <a:tc>
@@ -2693,7 +2767,9 @@
                       </a:solidFill>
                       <a:prstDash val="solid"/>
                     </a:lnB>
-                    <a:noFill/>
+                    <a:solidFill>
+                      <a:srgbClr val="DDEBF7"/>
+                    </a:solidFill>
                   </a:tcPr>
                 </a:tc>
                 <a:tc>
@@ -2740,7 +2816,9 @@
                       </a:solidFill>
                       <a:prstDash val="solid"/>
                     </a:lnB>
-                    <a:noFill/>
+                    <a:solidFill>
+                      <a:srgbClr val="DDEBF7"/>
+                    </a:solidFill>
                   </a:tcPr>
                 </a:tc>
                 <a:tc>
@@ -2787,7 +2865,9 @@
                       </a:solidFill>
                       <a:prstDash val="solid"/>
                     </a:lnB>
-                    <a:noFill/>
+                    <a:solidFill>
+                      <a:srgbClr val="DDEBF7"/>
+                    </a:solidFill>
                   </a:tcPr>
                 </a:tc>
               </a:tr>
@@ -2837,7 +2917,7 @@
                       <a:prstDash val="solid"/>
                     </a:lnB>
                     <a:solidFill>
-                      <a:srgbClr val="FBE6E2"/>
+                      <a:srgbClr val="FCE4D6"/>
                     </a:solidFill>
                   </a:tcPr>
                 </a:tc>
@@ -2886,7 +2966,7 @@
                       <a:prstDash val="solid"/>
                     </a:lnB>
                     <a:solidFill>
-                      <a:srgbClr val="FAE6DD"/>
+                      <a:srgbClr val="FCE4D6"/>
                     </a:solidFill>
                   </a:tcPr>
                 </a:tc>
@@ -2934,7 +3014,9 @@
                       </a:solidFill>
                       <a:prstDash val="solid"/>
                     </a:lnB>
-                    <a:noFill/>
+                    <a:solidFill>
+                      <a:srgbClr val="FCE4D6"/>
+                    </a:solidFill>
                   </a:tcPr>
                 </a:tc>
                 <a:tc>
@@ -2981,7 +3063,9 @@
                       </a:solidFill>
                       <a:prstDash val="solid"/>
                     </a:lnB>
-                    <a:noFill/>
+                    <a:solidFill>
+                      <a:srgbClr val="FCE4D6"/>
+                    </a:solidFill>
                   </a:tcPr>
                 </a:tc>
                 <a:tc>
@@ -3028,7 +3112,9 @@
                       </a:solidFill>
                       <a:prstDash val="solid"/>
                     </a:lnB>
-                    <a:noFill/>
+                    <a:solidFill>
+                      <a:srgbClr val="FCE4D6"/>
+                    </a:solidFill>
                   </a:tcPr>
                 </a:tc>
               </a:tr>
@@ -3067,7 +3153,7 @@
                       <a:prstDash val="solid"/>
                     </a:lnB>
                     <a:solidFill>
-                      <a:srgbClr val="FBE6E2"/>
+                      <a:srgbClr val="FCE4D6"/>
                     </a:solidFill>
                   </a:tcPr>
                 </a:tc>
@@ -3105,7 +3191,7 @@
                       <a:prstDash val="solid"/>
                     </a:lnB>
                     <a:solidFill>
-                      <a:srgbClr val="FAE6DD"/>
+                      <a:srgbClr val="FCE4D6"/>
                     </a:solidFill>
                   </a:tcPr>
                 </a:tc>
@@ -3153,7 +3239,9 @@
                       </a:solidFill>
                       <a:prstDash val="solid"/>
                     </a:lnB>
-                    <a:noFill/>
+                    <a:solidFill>
+                      <a:srgbClr val="FCE4D6"/>
+                    </a:solidFill>
                   </a:tcPr>
                 </a:tc>
                 <a:tc>
@@ -3200,7 +3288,9 @@
                       </a:solidFill>
                       <a:prstDash val="solid"/>
                     </a:lnB>
-                    <a:noFill/>
+                    <a:solidFill>
+                      <a:srgbClr val="FCE4D6"/>
+                    </a:solidFill>
                   </a:tcPr>
                 </a:tc>
                 <a:tc>
@@ -3247,7 +3337,9 @@
                       </a:solidFill>
                       <a:prstDash val="solid"/>
                     </a:lnB>
-                    <a:noFill/>
+                    <a:solidFill>
+                      <a:srgbClr val="FCE4D6"/>
+                    </a:solidFill>
                   </a:tcPr>
                 </a:tc>
               </a:tr>
@@ -3286,7 +3378,7 @@
                       <a:prstDash val="solid"/>
                     </a:lnB>
                     <a:solidFill>
-                      <a:srgbClr val="FBE6E2"/>
+                      <a:srgbClr val="FCE4D6"/>
                     </a:solidFill>
                   </a:tcPr>
                 </a:tc>
@@ -3324,7 +3416,7 @@
                       <a:prstDash val="solid"/>
                     </a:lnB>
                     <a:solidFill>
-                      <a:srgbClr val="FAE6DD"/>
+                      <a:srgbClr val="FCE4D6"/>
                     </a:solidFill>
                   </a:tcPr>
                 </a:tc>
@@ -3372,7 +3464,9 @@
                       </a:solidFill>
                       <a:prstDash val="solid"/>
                     </a:lnB>
-                    <a:noFill/>
+                    <a:solidFill>
+                      <a:srgbClr val="FCE4D6"/>
+                    </a:solidFill>
                   </a:tcPr>
                 </a:tc>
                 <a:tc>
@@ -3419,7 +3513,9 @@
                       </a:solidFill>
                       <a:prstDash val="solid"/>
                     </a:lnB>
-                    <a:noFill/>
+                    <a:solidFill>
+                      <a:srgbClr val="FCE4D6"/>
+                    </a:solidFill>
                   </a:tcPr>
                 </a:tc>
                 <a:tc>
@@ -3466,7 +3562,9 @@
                       </a:solidFill>
                       <a:prstDash val="solid"/>
                     </a:lnB>
-                    <a:noFill/>
+                    <a:solidFill>
+                      <a:srgbClr val="FCE4D6"/>
+                    </a:solidFill>
                   </a:tcPr>
                 </a:tc>
               </a:tr>
@@ -3505,7 +3603,7 @@
                       <a:prstDash val="solid"/>
                     </a:lnB>
                     <a:solidFill>
-                      <a:srgbClr val="FBE6E2"/>
+                      <a:srgbClr val="FCE4D6"/>
                     </a:solidFill>
                   </a:tcPr>
                 </a:tc>
@@ -3543,7 +3641,7 @@
                       <a:prstDash val="solid"/>
                     </a:lnB>
                     <a:solidFill>
-                      <a:srgbClr val="FAE6DD"/>
+                      <a:srgbClr val="FCE4D6"/>
                     </a:solidFill>
                   </a:tcPr>
                 </a:tc>
@@ -3591,7 +3689,9 @@
                       </a:solidFill>
                       <a:prstDash val="solid"/>
                     </a:lnB>
-                    <a:noFill/>
+                    <a:solidFill>
+                      <a:srgbClr val="FCE4D6"/>
+                    </a:solidFill>
                   </a:tcPr>
                 </a:tc>
                 <a:tc>
@@ -3638,7 +3738,9 @@
                       </a:solidFill>
                       <a:prstDash val="solid"/>
                     </a:lnB>
-                    <a:noFill/>
+                    <a:solidFill>
+                      <a:srgbClr val="FCE4D6"/>
+                    </a:solidFill>
                   </a:tcPr>
                 </a:tc>
                 <a:tc>
@@ -3685,7 +3787,9 @@
                       </a:solidFill>
                       <a:prstDash val="solid"/>
                     </a:lnB>
-                    <a:noFill/>
+                    <a:solidFill>
+                      <a:srgbClr val="FCE4D6"/>
+                    </a:solidFill>
                   </a:tcPr>
                 </a:tc>
               </a:tr>
@@ -3724,7 +3828,7 @@
                       <a:prstDash val="solid"/>
                     </a:lnB>
                     <a:solidFill>
-                      <a:srgbClr val="FBE6E2"/>
+                      <a:srgbClr val="FCE4D6"/>
                     </a:solidFill>
                   </a:tcPr>
                 </a:tc>
@@ -3762,7 +3866,7 @@
                       <a:prstDash val="solid"/>
                     </a:lnB>
                     <a:solidFill>
-                      <a:srgbClr val="FAE6DD"/>
+                      <a:srgbClr val="FCE4D6"/>
                     </a:solidFill>
                   </a:tcPr>
                 </a:tc>
@@ -3810,7 +3914,9 @@
                       </a:solidFill>
                       <a:prstDash val="solid"/>
                     </a:lnB>
-                    <a:noFill/>
+                    <a:solidFill>
+                      <a:srgbClr val="FCE4D6"/>
+                    </a:solidFill>
                   </a:tcPr>
                 </a:tc>
                 <a:tc>
@@ -3857,7 +3963,9 @@
                       </a:solidFill>
                       <a:prstDash val="solid"/>
                     </a:lnB>
-                    <a:noFill/>
+                    <a:solidFill>
+                      <a:srgbClr val="FCE4D6"/>
+                    </a:solidFill>
                   </a:tcPr>
                 </a:tc>
                 <a:tc>
@@ -3904,7 +4012,9 @@
                       </a:solidFill>
                       <a:prstDash val="solid"/>
                     </a:lnB>
-                    <a:noFill/>
+                    <a:solidFill>
+                      <a:srgbClr val="FCE4D6"/>
+                    </a:solidFill>
                   </a:tcPr>
                 </a:tc>
               </a:tr>
@@ -3943,7 +4053,7 @@
                       <a:prstDash val="solid"/>
                     </a:lnB>
                     <a:solidFill>
-                      <a:srgbClr val="FBE6E2"/>
+                      <a:srgbClr val="FCE4D6"/>
                     </a:solidFill>
                   </a:tcPr>
                 </a:tc>
@@ -3981,7 +4091,7 @@
                       <a:prstDash val="solid"/>
                     </a:lnB>
                     <a:solidFill>
-                      <a:srgbClr val="FAE6DD"/>
+                      <a:srgbClr val="FCE4D6"/>
                     </a:solidFill>
                   </a:tcPr>
                 </a:tc>
@@ -4029,7 +4139,9 @@
                       </a:solidFill>
                       <a:prstDash val="solid"/>
                     </a:lnB>
-                    <a:noFill/>
+                    <a:solidFill>
+                      <a:srgbClr val="FCE4D6"/>
+                    </a:solidFill>
                   </a:tcPr>
                 </a:tc>
                 <a:tc>
@@ -4076,7 +4188,9 @@
                       </a:solidFill>
                       <a:prstDash val="solid"/>
                     </a:lnB>
-                    <a:noFill/>
+                    <a:solidFill>
+                      <a:srgbClr val="FCE4D6"/>
+                    </a:solidFill>
                   </a:tcPr>
                 </a:tc>
                 <a:tc>
@@ -4123,7 +4237,9 @@
                       </a:solidFill>
                       <a:prstDash val="solid"/>
                     </a:lnB>
-                    <a:noFill/>
+                    <a:solidFill>
+                      <a:srgbClr val="FCE4D6"/>
+                    </a:solidFill>
                   </a:tcPr>
                 </a:tc>
               </a:tr>
@@ -4162,7 +4278,7 @@
                       <a:prstDash val="solid"/>
                     </a:lnB>
                     <a:solidFill>
-                      <a:srgbClr val="FBE6E2"/>
+                      <a:srgbClr val="FCE4D6"/>
                     </a:solidFill>
                   </a:tcPr>
                 </a:tc>
@@ -4200,7 +4316,7 @@
                       <a:prstDash val="solid"/>
                     </a:lnB>
                     <a:solidFill>
-                      <a:srgbClr val="FAE6DD"/>
+                      <a:srgbClr val="FCE4D6"/>
                     </a:solidFill>
                   </a:tcPr>
                 </a:tc>
@@ -4248,7 +4364,9 @@
                       </a:solidFill>
                       <a:prstDash val="solid"/>
                     </a:lnB>
-                    <a:noFill/>
+                    <a:solidFill>
+                      <a:srgbClr val="FCE4D6"/>
+                    </a:solidFill>
                   </a:tcPr>
                 </a:tc>
                 <a:tc>
@@ -4295,7 +4413,9 @@
                       </a:solidFill>
                       <a:prstDash val="solid"/>
                     </a:lnB>
-                    <a:noFill/>
+                    <a:solidFill>
+                      <a:srgbClr val="FCE4D6"/>
+                    </a:solidFill>
                   </a:tcPr>
                 </a:tc>
                 <a:tc>
@@ -4342,7 +4462,9 @@
                       </a:solidFill>
                       <a:prstDash val="solid"/>
                     </a:lnB>
-                    <a:noFill/>
+                    <a:solidFill>
+                      <a:srgbClr val="FCE4D6"/>
+                    </a:solidFill>
                   </a:tcPr>
                 </a:tc>
               </a:tr>
@@ -4391,7 +4513,9 @@
                       </a:solidFill>
                       <a:prstDash val="solid"/>
                     </a:lnB>
-                    <a:noFill/>
+                    <a:solidFill>
+                      <a:srgbClr val="EEF4F3"/>
+                    </a:solidFill>
                   </a:tcPr>
                 </a:tc>
                 <a:tc rowSpan="2">
@@ -4438,7 +4562,9 @@
                       </a:solidFill>
                       <a:prstDash val="solid"/>
                     </a:lnB>
-                    <a:noFill/>
+                    <a:solidFill>
+                      <a:srgbClr val="EEF4F3"/>
+                    </a:solidFill>
                   </a:tcPr>
                 </a:tc>
                 <a:tc>
@@ -4485,7 +4611,9 @@
                       </a:solidFill>
                       <a:prstDash val="solid"/>
                     </a:lnB>
-                    <a:noFill/>
+                    <a:solidFill>
+                      <a:srgbClr val="EEF4F3"/>
+                    </a:solidFill>
                   </a:tcPr>
                 </a:tc>
                 <a:tc>
@@ -4532,7 +4660,9 @@
                       </a:solidFill>
                       <a:prstDash val="solid"/>
                     </a:lnB>
-                    <a:noFill/>
+                    <a:solidFill>
+                      <a:srgbClr val="EEF4F3"/>
+                    </a:solidFill>
                   </a:tcPr>
                 </a:tc>
                 <a:tc>
@@ -4579,7 +4709,9 @@
                       </a:solidFill>
                       <a:prstDash val="solid"/>
                     </a:lnB>
-                    <a:noFill/>
+                    <a:solidFill>
+                      <a:srgbClr val="EEF4F3"/>
+                    </a:solidFill>
                   </a:tcPr>
                 </a:tc>
               </a:tr>
@@ -4617,7 +4749,9 @@
                       </a:solidFill>
                       <a:prstDash val="solid"/>
                     </a:lnB>
-                    <a:noFill/>
+                    <a:solidFill>
+                      <a:srgbClr val="EEF4F3"/>
+                    </a:solidFill>
                   </a:tcPr>
                 </a:tc>
                 <a:tc vMerge="1">
@@ -4653,7 +4787,9 @@
                       </a:solidFill>
                       <a:prstDash val="solid"/>
                     </a:lnB>
-                    <a:noFill/>
+                    <a:solidFill>
+                      <a:srgbClr val="EEF4F3"/>
+                    </a:solidFill>
                   </a:tcPr>
                 </a:tc>
                 <a:tc>
@@ -4700,7 +4836,9 @@
                       </a:solidFill>
                       <a:prstDash val="solid"/>
                     </a:lnB>
-                    <a:noFill/>
+                    <a:solidFill>
+                      <a:srgbClr val="EEF4F3"/>
+                    </a:solidFill>
                   </a:tcPr>
                 </a:tc>
                 <a:tc>
@@ -4747,7 +4885,9 @@
                       </a:solidFill>
                       <a:prstDash val="solid"/>
                     </a:lnB>
-                    <a:noFill/>
+                    <a:solidFill>
+                      <a:srgbClr val="EEF4F3"/>
+                    </a:solidFill>
                   </a:tcPr>
                 </a:tc>
                 <a:tc>
@@ -4794,7 +4934,9 @@
                       </a:solidFill>
                       <a:prstDash val="solid"/>
                     </a:lnB>
-                    <a:noFill/>
+                    <a:solidFill>
+                      <a:srgbClr val="EEF4F3"/>
+                    </a:solidFill>
                   </a:tcPr>
                 </a:tc>
               </a:tr>
@@ -4844,7 +4986,7 @@
                       <a:prstDash val="solid"/>
                     </a:lnB>
                     <a:solidFill>
-                      <a:srgbClr val="F7DE72"/>
+                      <a:srgbClr val="FFE699"/>
                     </a:solidFill>
                   </a:tcPr>
                 </a:tc>
@@ -4915,7 +5057,7 @@
                       <a:prstDash val="solid"/>
                     </a:lnB>
                     <a:solidFill>
-                      <a:srgbClr val="FAE476"/>
+                      <a:srgbClr val="FFE699"/>
                     </a:solidFill>
                   </a:tcPr>
                 </a:tc>
@@ -4964,7 +5106,7 @@
                       <a:prstDash val="solid"/>
                     </a:lnB>
                     <a:solidFill>
-                      <a:srgbClr val="FAE97C"/>
+                      <a:srgbClr val="FFE699"/>
                     </a:solidFill>
                   </a:tcPr>
                 </a:tc>
@@ -5013,7 +5155,7 @@
                       <a:prstDash val="solid"/>
                     </a:lnB>
                     <a:solidFill>
-                      <a:srgbClr val="FAE678"/>
+                      <a:srgbClr val="FFE699"/>
                     </a:solidFill>
                   </a:tcPr>
                 </a:tc>
@@ -5062,7 +5204,7 @@
                       <a:prstDash val="solid"/>
                     </a:lnB>
                     <a:solidFill>
-                      <a:srgbClr val="F9E275"/>
+                      <a:srgbClr val="FFE699"/>
                     </a:solidFill>
                   </a:tcPr>
                 </a:tc>
@@ -5113,7 +5255,7 @@
                       <a:prstDash val="solid"/>
                     </a:lnB>
                     <a:solidFill>
-                      <a:srgbClr val="73B7F9"/>
+                      <a:srgbClr val="9BC2E6"/>
                     </a:solidFill>
                   </a:tcPr>
                 </a:tc>
@@ -5184,7 +5326,7 @@
                       <a:prstDash val="solid"/>
                     </a:lnB>
                     <a:solidFill>
-                      <a:srgbClr val="76BAFB"/>
+                      <a:srgbClr val="9BC2E6"/>
                     </a:solidFill>
                   </a:tcPr>
                 </a:tc>
@@ -5233,7 +5375,7 @@
                       <a:prstDash val="solid"/>
                     </a:lnB>
                     <a:solidFill>
-                      <a:srgbClr val="7CC5FC"/>
+                      <a:srgbClr val="9BC2E6"/>
                     </a:solidFill>
                   </a:tcPr>
                 </a:tc>
@@ -5282,7 +5424,7 @@
                       <a:prstDash val="solid"/>
                     </a:lnB>
                     <a:solidFill>
-                      <a:srgbClr val="7FC1F6"/>
+                      <a:srgbClr val="9BC2E6"/>
                     </a:solidFill>
                   </a:tcPr>
                 </a:tc>
@@ -5331,7 +5473,7 @@
                       <a:prstDash val="solid"/>
                     </a:lnB>
                     <a:solidFill>
-                      <a:srgbClr val="82BEF6"/>
+                      <a:srgbClr val="9BC2E6"/>
                     </a:solidFill>
                   </a:tcPr>
                 </a:tc>
@@ -5371,7 +5513,7 @@
                       <a:prstDash val="solid"/>
                     </a:lnB>
                     <a:solidFill>
-                      <a:srgbClr val="73B7F9"/>
+                      <a:srgbClr val="9BC2E6"/>
                     </a:solidFill>
                   </a:tcPr>
                 </a:tc>
@@ -5409,7 +5551,7 @@
                       <a:prstDash val="solid"/>
                     </a:lnB>
                     <a:solidFill>
-                      <a:srgbClr val="76BAFB"/>
+                      <a:srgbClr val="9BC2E6"/>
                     </a:solidFill>
                   </a:tcPr>
                 </a:tc>
@@ -5458,7 +5600,7 @@
                       <a:prstDash val="solid"/>
                     </a:lnB>
                     <a:solidFill>
-                      <a:srgbClr val="84C7F9"/>
+                      <a:srgbClr val="9BC2E6"/>
                     </a:solidFill>
                   </a:tcPr>
                 </a:tc>
@@ -5507,7 +5649,7 @@
                       <a:prstDash val="solid"/>
                     </a:lnB>
                     <a:solidFill>
-                      <a:srgbClr val="80C1F8"/>
+                      <a:srgbClr val="9BC2E6"/>
                     </a:solidFill>
                   </a:tcPr>
                 </a:tc>
@@ -5556,7 +5698,7 @@
                       <a:prstDash val="solid"/>
                     </a:lnB>
                     <a:solidFill>
-                      <a:srgbClr val="80BFF8"/>
+                      <a:srgbClr val="9BC2E6"/>
                     </a:solidFill>
                   </a:tcPr>
                 </a:tc>
@@ -5596,7 +5738,7 @@
                       <a:prstDash val="solid"/>
                     </a:lnB>
                     <a:solidFill>
-                      <a:srgbClr val="73B7F9"/>
+                      <a:srgbClr val="9BC2E6"/>
                     </a:solidFill>
                   </a:tcPr>
                 </a:tc>
@@ -5634,7 +5776,7 @@
                       <a:prstDash val="solid"/>
                     </a:lnB>
                     <a:solidFill>
-                      <a:srgbClr val="76BAFB"/>
+                      <a:srgbClr val="9BC2E6"/>
                     </a:solidFill>
                   </a:tcPr>
                 </a:tc>
@@ -5683,7 +5825,7 @@
                       <a:prstDash val="solid"/>
                     </a:lnB>
                     <a:solidFill>
-                      <a:srgbClr val="89C5F9"/>
+                      <a:srgbClr val="9BC2E6"/>
                     </a:solidFill>
                   </a:tcPr>
                 </a:tc>
@@ -5732,7 +5874,7 @@
                       <a:prstDash val="solid"/>
                     </a:lnB>
                     <a:solidFill>
-                      <a:srgbClr val="85C1F7"/>
+                      <a:srgbClr val="9BC2E6"/>
                     </a:solidFill>
                   </a:tcPr>
                 </a:tc>
@@ -5781,7 +5923,7 @@
                       <a:prstDash val="solid"/>
                     </a:lnB>
                     <a:solidFill>
-                      <a:srgbClr val="83C1F8"/>
+                      <a:srgbClr val="9BC2E6"/>
                     </a:solidFill>
                   </a:tcPr>
                 </a:tc>
@@ -5821,7 +5963,7 @@
                       <a:prstDash val="solid"/>
                     </a:lnB>
                     <a:solidFill>
-                      <a:srgbClr val="73B7F9"/>
+                      <a:srgbClr val="9BC2E6"/>
                     </a:solidFill>
                   </a:tcPr>
                 </a:tc>
@@ -5859,7 +6001,7 @@
                       <a:prstDash val="solid"/>
                     </a:lnB>
                     <a:solidFill>
-                      <a:srgbClr val="76BAFB"/>
+                      <a:srgbClr val="9BC2E6"/>
                     </a:solidFill>
                   </a:tcPr>
                 </a:tc>
@@ -5908,7 +6050,7 @@
                       <a:prstDash val="solid"/>
                     </a:lnB>
                     <a:solidFill>
-                      <a:srgbClr val="7FC2FA"/>
+                      <a:srgbClr val="9BC2E6"/>
                     </a:solidFill>
                   </a:tcPr>
                 </a:tc>
@@ -5957,7 +6099,7 @@
                       <a:prstDash val="solid"/>
                     </a:lnB>
                     <a:solidFill>
-                      <a:srgbClr val="80BFF8"/>
+                      <a:srgbClr val="9BC2E6"/>
                     </a:solidFill>
                   </a:tcPr>
                 </a:tc>
@@ -6006,7 +6148,7 @@
                       <a:prstDash val="solid"/>
                     </a:lnB>
                     <a:solidFill>
-                      <a:srgbClr val="83BFF6"/>
+                      <a:srgbClr val="9BC2E6"/>
                     </a:solidFill>
                   </a:tcPr>
                 </a:tc>
@@ -6046,7 +6188,7 @@
                       <a:prstDash val="solid"/>
                     </a:lnB>
                     <a:solidFill>
-                      <a:srgbClr val="73B7F9"/>
+                      <a:srgbClr val="9BC2E6"/>
                     </a:solidFill>
                   </a:tcPr>
                 </a:tc>
@@ -6084,7 +6226,7 @@
                       <a:prstDash val="solid"/>
                     </a:lnB>
                     <a:solidFill>
-                      <a:srgbClr val="76BAFB"/>
+                      <a:srgbClr val="9BC2E6"/>
                     </a:solidFill>
                   </a:tcPr>
                 </a:tc>
@@ -6133,7 +6275,7 @@
                       <a:prstDash val="solid"/>
                     </a:lnB>
                     <a:solidFill>
-                      <a:srgbClr val="7CC1FB"/>
+                      <a:srgbClr val="9BC2E6"/>
                     </a:solidFill>
                   </a:tcPr>
                 </a:tc>
@@ -6182,7 +6324,7 @@
                       <a:prstDash val="solid"/>
                     </a:lnB>
                     <a:solidFill>
-                      <a:srgbClr val="7CBDF9"/>
+                      <a:srgbClr val="9BC2E6"/>
                     </a:solidFill>
                   </a:tcPr>
                 </a:tc>
@@ -6231,7 +6373,7 @@
                       <a:prstDash val="solid"/>
                     </a:lnB>
                     <a:solidFill>
-                      <a:srgbClr val="80BEF7"/>
+                      <a:srgbClr val="9BC2E6"/>
                     </a:solidFill>
                   </a:tcPr>
                 </a:tc>
@@ -6271,7 +6413,7 @@
                       <a:prstDash val="solid"/>
                     </a:lnB>
                     <a:solidFill>
-                      <a:srgbClr val="73B7F9"/>
+                      <a:srgbClr val="9BC2E6"/>
                     </a:solidFill>
                   </a:tcPr>
                 </a:tc>
@@ -6309,7 +6451,7 @@
                       <a:prstDash val="solid"/>
                     </a:lnB>
                     <a:solidFill>
-                      <a:srgbClr val="76BAFB"/>
+                      <a:srgbClr val="9BC2E6"/>
                     </a:solidFill>
                   </a:tcPr>
                 </a:tc>
@@ -6358,7 +6500,7 @@
                       <a:prstDash val="solid"/>
                     </a:lnB>
                     <a:solidFill>
-                      <a:srgbClr val="7FBFFA"/>
+                      <a:srgbClr val="9BC2E6"/>
                     </a:solidFill>
                   </a:tcPr>
                 </a:tc>
@@ -6407,7 +6549,7 @@
                       <a:prstDash val="solid"/>
                     </a:lnB>
                     <a:solidFill>
-                      <a:srgbClr val="7CBAF9"/>
+                      <a:srgbClr val="9BC2E6"/>
                     </a:solidFill>
                   </a:tcPr>
                 </a:tc>
@@ -6456,7 +6598,7 @@
                       <a:prstDash val="solid"/>
                     </a:lnB>
                     <a:solidFill>
-                      <a:srgbClr val="7EBDF7"/>
+                      <a:srgbClr val="9BC2E6"/>
                     </a:solidFill>
                   </a:tcPr>
                 </a:tc>
@@ -6496,7 +6638,7 @@
                       <a:prstDash val="solid"/>
                     </a:lnB>
                     <a:solidFill>
-                      <a:srgbClr val="73B7F9"/>
+                      <a:srgbClr val="9BC2E6"/>
                     </a:solidFill>
                   </a:tcPr>
                 </a:tc>
@@ -6534,7 +6676,7 @@
                       <a:prstDash val="solid"/>
                     </a:lnB>
                     <a:solidFill>
-                      <a:srgbClr val="76BAFB"/>
+                      <a:srgbClr val="9BC2E6"/>
                     </a:solidFill>
                   </a:tcPr>
                 </a:tc>
@@ -6583,7 +6725,7 @@
                       <a:prstDash val="solid"/>
                     </a:lnB>
                     <a:solidFill>
-                      <a:srgbClr val="80C1FB"/>
+                      <a:srgbClr val="9BC2E6"/>
                     </a:solidFill>
                   </a:tcPr>
                 </a:tc>
@@ -6632,7 +6774,7 @@
                       <a:prstDash val="solid"/>
                     </a:lnB>
                     <a:solidFill>
-                      <a:srgbClr val="7FBDF8"/>
+                      <a:srgbClr val="9BC2E6"/>
                     </a:solidFill>
                   </a:tcPr>
                 </a:tc>
@@ -6681,7 +6823,7 @@
                       <a:prstDash val="solid"/>
                     </a:lnB>
                     <a:solidFill>
-                      <a:srgbClr val="7DBDF8"/>
+                      <a:srgbClr val="9BC2E6"/>
                     </a:solidFill>
                   </a:tcPr>
                 </a:tc>
@@ -6721,7 +6863,7 @@
                       <a:prstDash val="solid"/>
                     </a:lnB>
                     <a:solidFill>
-                      <a:srgbClr val="73B7F9"/>
+                      <a:srgbClr val="9BC2E6"/>
                     </a:solidFill>
                   </a:tcPr>
                 </a:tc>
@@ -6759,7 +6901,7 @@
                       <a:prstDash val="solid"/>
                     </a:lnB>
                     <a:solidFill>
-                      <a:srgbClr val="76BAFB"/>
+                      <a:srgbClr val="9BC2E6"/>
                     </a:solidFill>
                   </a:tcPr>
                 </a:tc>
@@ -6808,7 +6950,7 @@
                       <a:prstDash val="solid"/>
                     </a:lnB>
                     <a:solidFill>
-                      <a:srgbClr val="7ABCFA"/>
+                      <a:srgbClr val="9BC2E6"/>
                     </a:solidFill>
                   </a:tcPr>
                 </a:tc>
@@ -6857,7 +6999,7 @@
                       <a:prstDash val="solid"/>
                     </a:lnB>
                     <a:solidFill>
-                      <a:srgbClr val="7CBDF9"/>
+                      <a:srgbClr val="9BC2E6"/>
                     </a:solidFill>
                   </a:tcPr>
                 </a:tc>
@@ -6906,7 +7048,7 @@
                       <a:prstDash val="solid"/>
                     </a:lnB>
                     <a:solidFill>
-                      <a:srgbClr val="7EBCF6"/>
+                      <a:srgbClr val="9BC2E6"/>
                     </a:solidFill>
                   </a:tcPr>
                 </a:tc>
@@ -6923,8 +7065,8 @@
         </p:nvSpPr>
         <p:spPr>
           <a:xfrm>
-            <a:off x="2873759" y="9186425"/>
-            <a:ext cx="491727" cy="335280"/>
+            <a:off x="2873759" y="9228865"/>
+            <a:ext cx="491727" cy="250400"/>
           </a:xfrm>
           <a:prstGeom prst="rect">
             <a:avLst/>
@@ -6939,12 +7081,12 @@
           <a:p>
             <a:pPr algn="l">
               <a:lnSpc>
-                <a:spcPts val="2640"/>
+                <a:spcPts val="1972"/>
               </a:lnSpc>
               <a:buNone/>
             </a:pPr>
             <a:r>
-              <a:rPr lang="en-US" sz="2200" spc="-264" dirty="0">
+              <a:rPr lang="en-US" sz="1643" spc="-116" dirty="0">
                 <a:solidFill>
                   <a:srgbClr val="000000"/>
                 </a:solidFill>

</xml_diff>